<commit_message>
Kay Park proposal: add estimated monthly total
Co-Authored-By: Claude Opus 5.5 <noreply@anthropic.com>
Claude-Session: https://claude.ai/code/session_018rW9XDNfHdsFfA3jVzx9xH
</commit_message>
<xml_diff>
--- a/Kay_Park_Recreation_Proposal.pptx
+++ b/Kay_Park_Recreation_Proposal.pptx
@@ -8319,12 +8319,12 @@
         </p:nvSpPr>
         <p:spPr>
           <a:xfrm>
-            <a:off x="548640" y="4937760"/>
-            <a:ext cx="5303520" cy="1143000"/>
+            <a:off x="548640" y="4846320"/>
+            <a:ext cx="5303520" cy="1371600"/>
           </a:xfrm>
           <a:prstGeom prst="roundRect">
             <a:avLst>
-              <a:gd name="adj" fmla="val 6400"/>
+              <a:gd name="adj" fmla="val 5333"/>
             </a:avLst>
           </a:prstGeom>
           <a:solidFill>
@@ -8346,7 +8346,7 @@
         </p:nvSpPr>
         <p:spPr>
           <a:xfrm>
-            <a:off x="822960" y="5074920"/>
+            <a:off x="822960" y="4956048"/>
             <a:ext cx="4754880" cy="274320"/>
           </a:xfrm>
           <a:prstGeom prst="rect">
@@ -8379,14 +8379,14 @@
       </p:sp>
       <p:sp>
         <p:nvSpPr>
-          <p:cNvPr id="8" name="TOTAL – Gail to confirm"/>
+          <p:cNvPr id="8" name="Estimated total"/>
           <p:cNvSpPr txBox="1"/>
           <p:nvPr/>
         </p:nvSpPr>
         <p:spPr>
           <a:xfrm>
-            <a:off x="822960" y="5394960"/>
-            <a:ext cx="4754880" cy="548640"/>
+            <a:off x="822960" y="5257800"/>
+            <a:ext cx="4754880" cy="502920"/>
           </a:xfrm>
           <a:prstGeom prst="rect">
             <a:avLst/>
@@ -8410,7 +8410,7 @@
                 <a:ea typeface="Cambria" pitchFamily="34" charset="-122"/>
                 <a:cs typeface="Cambria" pitchFamily="34" charset="-120"/>
               </a:rPr>
-              <a:t>$X,XXX – $X,XXX / month</a:t>
+              <a:t>About $3,600 – $4,100 / month</a:t>
             </a:r>
             <a:endParaRPr lang="en-US" sz="2600" dirty="0"/>
           </a:p>
@@ -8419,6 +8419,45 @@
       <p:sp>
         <p:nvSpPr>
           <p:cNvPr id="9" name="Text 6"/>
+          <p:cNvSpPr txBox="1"/>
+          <p:nvPr/>
+        </p:nvSpPr>
+        <p:spPr>
+          <a:xfrm>
+            <a:off x="822960" y="5806440"/>
+            <a:ext cx="4846320" cy="320040"/>
+          </a:xfrm>
+          <a:prstGeom prst="rect">
+            <a:avLst/>
+          </a:prstGeom>
+          <a:noFill/>
+          <a:ln/>
+        </p:spPr>
+        <p:txBody>
+          <a:bodyPr wrap="square" lIns="0" tIns="0" rIns="0" bIns="0" rtlCol="0" anchor="ctr"/>
+          <a:lstStyle/>
+          <a:p>
+            <a:pPr indent="0" marL="0">
+              <a:buNone/>
+            </a:pPr>
+            <a:r>
+              <a:rPr lang="en-US" sz="1050" dirty="0">
+                <a:solidFill>
+                  <a:srgbClr val="BFC9D3"/>
+                </a:solidFill>
+                <a:latin typeface="Calibri" pitchFamily="34" charset="0"/>
+                <a:ea typeface="Calibri" pitchFamily="34" charset="-122"/>
+                <a:cs typeface="Calibri" pitchFamily="34" charset="-120"/>
+              </a:rPr>
+              <a:t>173 hrs/month (40 hrs × 52 weeks ÷ 12) at $15–$18/hr, plus the $1,000 agency fee</a:t>
+            </a:r>
+            <a:endParaRPr lang="en-US" sz="1050" dirty="0"/>
+          </a:p>
+        </p:txBody>
+      </p:sp>
+      <p:sp>
+        <p:nvSpPr>
+          <p:cNvPr id="10" name="Text 7"/>
           <p:cNvSpPr txBox="1"/>
           <p:nvPr/>
         </p:nvSpPr>

</xml_diff>